<commit_message>
Add Franchini logo to Build Week presentation
</commit_message>
<xml_diff>
--- a/deliverables/Robo-T-Rader_OpenAI_Build_Week_2026.pptx
+++ b/deliverables/Robo-T-Rader_OpenAI_Build_Week_2026.pptx
@@ -2,22 +2,22 @@
 <file path=ppt/presentation.xml><?xml version="1.0" encoding="utf-8"?>
 <p:presentation xmlns:p="http://schemas.openxmlformats.org/presentationml/2006/main">
   <p:sldMasterIdLst>
-    <p:sldMasterId xmlns:r="http://schemas.openxmlformats.org/officeDocument/2006/relationships" id="2147483648" r:id="Rc74bbde5d1fc4f9c"/>
+    <p:sldMasterId xmlns:r="http://schemas.openxmlformats.org/officeDocument/2006/relationships" id="2147483648" r:id="Rc58b740cd73649bc"/>
   </p:sldMasterIdLst>
   <p:notesMasterIdLst>
-    <p:notesMasterId xmlns:r="http://schemas.openxmlformats.org/officeDocument/2006/relationships" r:id="R06387351ce3e4283"/>
+    <p:notesMasterId xmlns:r="http://schemas.openxmlformats.org/officeDocument/2006/relationships" r:id="R1202769f2312400b"/>
   </p:notesMasterIdLst>
   <p:sldIdLst>
-    <p:sldId xmlns:r="http://schemas.openxmlformats.org/officeDocument/2006/relationships" id="256" r:id="Rd77180e57fc5418a"/>
-    <p:sldId xmlns:r="http://schemas.openxmlformats.org/officeDocument/2006/relationships" id="257" r:id="R3aae73d2e77f4825"/>
-    <p:sldId xmlns:r="http://schemas.openxmlformats.org/officeDocument/2006/relationships" id="258" r:id="Rb3a2dbad60184b02"/>
-    <p:sldId xmlns:r="http://schemas.openxmlformats.org/officeDocument/2006/relationships" id="259" r:id="R3b87532a6c694f16"/>
-    <p:sldId xmlns:r="http://schemas.openxmlformats.org/officeDocument/2006/relationships" id="260" r:id="R74aea1237fa745b0"/>
-    <p:sldId xmlns:r="http://schemas.openxmlformats.org/officeDocument/2006/relationships" id="261" r:id="Re910d43d5e4e4c34"/>
-    <p:sldId xmlns:r="http://schemas.openxmlformats.org/officeDocument/2006/relationships" id="262" r:id="Rba9ad5a0f8ed417d"/>
-    <p:sldId xmlns:r="http://schemas.openxmlformats.org/officeDocument/2006/relationships" id="263" r:id="R77f0d63dab844209"/>
-    <p:sldId xmlns:r="http://schemas.openxmlformats.org/officeDocument/2006/relationships" id="264" r:id="R4f2016e74d354ba0"/>
-    <p:sldId xmlns:r="http://schemas.openxmlformats.org/officeDocument/2006/relationships" id="265" r:id="Rda7cac80333945d6"/>
+    <p:sldId xmlns:r="http://schemas.openxmlformats.org/officeDocument/2006/relationships" id="256" r:id="Rf695aa83d1734a8d"/>
+    <p:sldId xmlns:r="http://schemas.openxmlformats.org/officeDocument/2006/relationships" id="257" r:id="Refa66d3726c54257"/>
+    <p:sldId xmlns:r="http://schemas.openxmlformats.org/officeDocument/2006/relationships" id="258" r:id="Rc1a701c4d6544738"/>
+    <p:sldId xmlns:r="http://schemas.openxmlformats.org/officeDocument/2006/relationships" id="259" r:id="R1c3e187fa01d4381"/>
+    <p:sldId xmlns:r="http://schemas.openxmlformats.org/officeDocument/2006/relationships" id="260" r:id="Re7d113e59e284240"/>
+    <p:sldId xmlns:r="http://schemas.openxmlformats.org/officeDocument/2006/relationships" id="261" r:id="Rca64f05c918549b6"/>
+    <p:sldId xmlns:r="http://schemas.openxmlformats.org/officeDocument/2006/relationships" id="262" r:id="R535747d4987a4ae9"/>
+    <p:sldId xmlns:r="http://schemas.openxmlformats.org/officeDocument/2006/relationships" id="263" r:id="R7e0e182465c6465d"/>
+    <p:sldId xmlns:r="http://schemas.openxmlformats.org/officeDocument/2006/relationships" id="264" r:id="R5cb6238a4d9f465c"/>
+    <p:sldId xmlns:r="http://schemas.openxmlformats.org/officeDocument/2006/relationships" id="265" r:id="Rbfa45cb58cba41d4"/>
   </p:sldIdLst>
   <p:sldSz cx="12192000" cy="6858000"/>
   <p:notesSz cx="6858000" cy="9144000"/>
@@ -1158,7 +1158,7 @@
   </p:cSld>
   <p:clrMap bg1="lt1" tx1="dk1" bg2="lt2" tx2="dk2" accent1="accent1" accent2="accent2" accent3="accent3" accent4="accent4" accent5="accent5" accent6="accent6" hlink="hlink" folHlink="folHlink"/>
   <p:sldLayoutIdLst>
-    <p:sldLayoutId xmlns:r="http://schemas.openxmlformats.org/officeDocument/2006/relationships" id="2147483649" r:id="R0fe5a44a0a924040"/>
+    <p:sldLayoutId xmlns:r="http://schemas.openxmlformats.org/officeDocument/2006/relationships" id="2147483649" r:id="Rdbc38080a8e546d1"/>
   </p:sldLayoutIdLst>
   <p:txStyles>
     <p:titleStyle>
@@ -1563,6 +1563,7 @@
           <a:lstStyle xmlns:a="http://schemas.openxmlformats.org/drawingml/2006/main"/>
           <a:p xmlns:a="http://schemas.openxmlformats.org/drawingml/2006/main">
             <a:pPr algn="l">
+              <a:buNone/>
               <a:defRPr sz="900" b="1">
                 <a:solidFill>
                   <a:srgbClr val="8DE0C7"/>
@@ -1627,6 +1628,7 @@
           <a:lstStyle xmlns:a="http://schemas.openxmlformats.org/drawingml/2006/main"/>
           <a:p xmlns:a="http://schemas.openxmlformats.org/drawingml/2006/main">
             <a:pPr algn="l">
+              <a:buNone/>
               <a:defRPr sz="2325" b="1">
                 <a:solidFill>
                   <a:srgbClr val="FFFFFF"/>
@@ -1691,6 +1693,7 @@
           <a:lstStyle xmlns:a="http://schemas.openxmlformats.org/drawingml/2006/main"/>
           <a:p xmlns:a="http://schemas.openxmlformats.org/drawingml/2006/main">
             <a:pPr algn="l">
+              <a:buNone/>
               <a:defRPr sz="1575" b="0">
                 <a:solidFill>
                   <a:srgbClr val="D7E2DD"/>
@@ -1823,6 +1826,7 @@
           <a:lstStyle xmlns:a="http://schemas.openxmlformats.org/drawingml/2006/main"/>
           <a:p xmlns:a="http://schemas.openxmlformats.org/drawingml/2006/main">
             <a:pPr algn="l">
+              <a:buNone/>
               <a:defRPr sz="2100" b="1">
                 <a:solidFill>
                   <a:srgbClr val="17202A"/>
@@ -1887,6 +1891,7 @@
           <a:lstStyle xmlns:a="http://schemas.openxmlformats.org/drawingml/2006/main"/>
           <a:p xmlns:a="http://schemas.openxmlformats.org/drawingml/2006/main">
             <a:pPr algn="l">
+              <a:buNone/>
               <a:defRPr sz="900" b="0">
                 <a:solidFill>
                   <a:srgbClr val="5F6B64"/>
@@ -2019,6 +2024,7 @@
           <a:lstStyle xmlns:a="http://schemas.openxmlformats.org/drawingml/2006/main"/>
           <a:p xmlns:a="http://schemas.openxmlformats.org/drawingml/2006/main">
             <a:pPr algn="l">
+              <a:buNone/>
               <a:defRPr sz="2100" b="1">
                 <a:solidFill>
                   <a:srgbClr val="17202A"/>
@@ -2083,6 +2089,7 @@
           <a:lstStyle xmlns:a="http://schemas.openxmlformats.org/drawingml/2006/main"/>
           <a:p xmlns:a="http://schemas.openxmlformats.org/drawingml/2006/main">
             <a:pPr algn="l">
+              <a:buNone/>
               <a:defRPr sz="900" b="0">
                 <a:solidFill>
                   <a:srgbClr val="5F6B64"/>
@@ -2215,6 +2222,7 @@
           <a:lstStyle xmlns:a="http://schemas.openxmlformats.org/drawingml/2006/main"/>
           <a:p xmlns:a="http://schemas.openxmlformats.org/drawingml/2006/main">
             <a:pPr algn="l">
+              <a:buNone/>
               <a:defRPr sz="2100" b="1">
                 <a:solidFill>
                   <a:srgbClr val="17202A"/>
@@ -2279,6 +2287,7 @@
           <a:lstStyle xmlns:a="http://schemas.openxmlformats.org/drawingml/2006/main"/>
           <a:p xmlns:a="http://schemas.openxmlformats.org/drawingml/2006/main">
             <a:pPr algn="l">
+              <a:buNone/>
               <a:defRPr sz="900" b="0">
                 <a:solidFill>
                   <a:srgbClr val="5F6B64"/>
@@ -2411,6 +2420,7 @@
           <a:lstStyle xmlns:a="http://schemas.openxmlformats.org/drawingml/2006/main"/>
           <a:p xmlns:a="http://schemas.openxmlformats.org/drawingml/2006/main">
             <a:pPr algn="l">
+              <a:buNone/>
               <a:defRPr sz="2100" b="1">
                 <a:solidFill>
                   <a:srgbClr val="17202A"/>
@@ -2475,6 +2485,7 @@
           <a:lstStyle xmlns:a="http://schemas.openxmlformats.org/drawingml/2006/main"/>
           <a:p xmlns:a="http://schemas.openxmlformats.org/drawingml/2006/main">
             <a:pPr algn="l">
+              <a:buNone/>
               <a:defRPr sz="900" b="0">
                 <a:solidFill>
                   <a:srgbClr val="5F6B64"/>
@@ -2539,6 +2550,7 @@
           <a:lstStyle xmlns:a="http://schemas.openxmlformats.org/drawingml/2006/main"/>
           <a:p xmlns:a="http://schemas.openxmlformats.org/drawingml/2006/main">
             <a:pPr algn="l">
+              <a:buNone/>
               <a:defRPr sz="900" b="1">
                 <a:solidFill>
                   <a:srgbClr val="8DE0C7"/>
@@ -2636,6 +2648,7 @@
           <a:lstStyle xmlns:a="http://schemas.openxmlformats.org/drawingml/2006/main"/>
           <a:p xmlns:a="http://schemas.openxmlformats.org/drawingml/2006/main">
             <a:pPr algn="l">
+              <a:buNone/>
               <a:defRPr sz="1200" b="1">
                 <a:solidFill>
                   <a:srgbClr val="0F8A6A"/>
@@ -2700,6 +2713,7 @@
           <a:lstStyle xmlns:a="http://schemas.openxmlformats.org/drawingml/2006/main"/>
           <a:p xmlns:a="http://schemas.openxmlformats.org/drawingml/2006/main">
             <a:pPr algn="l">
+              <a:buNone/>
               <a:defRPr sz="863" b="0">
                 <a:solidFill>
                   <a:srgbClr val="17202A"/>
@@ -2797,6 +2811,7 @@
           <a:lstStyle xmlns:a="http://schemas.openxmlformats.org/drawingml/2006/main"/>
           <a:p xmlns:a="http://schemas.openxmlformats.org/drawingml/2006/main">
             <a:pPr algn="l">
+              <a:buNone/>
               <a:defRPr sz="1200" b="1">
                 <a:solidFill>
                   <a:srgbClr val="2E5EA7"/>
@@ -2861,6 +2876,7 @@
           <a:lstStyle xmlns:a="http://schemas.openxmlformats.org/drawingml/2006/main"/>
           <a:p xmlns:a="http://schemas.openxmlformats.org/drawingml/2006/main">
             <a:pPr algn="l">
+              <a:buNone/>
               <a:defRPr sz="863" b="0">
                 <a:solidFill>
                   <a:srgbClr val="17202A"/>
@@ -2958,6 +2974,7 @@
           <a:lstStyle xmlns:a="http://schemas.openxmlformats.org/drawingml/2006/main"/>
           <a:p xmlns:a="http://schemas.openxmlformats.org/drawingml/2006/main">
             <a:pPr algn="l">
+              <a:buNone/>
               <a:defRPr sz="1200" b="1">
                 <a:solidFill>
                   <a:srgbClr val="C98A21"/>
@@ -3022,6 +3039,7 @@
           <a:lstStyle xmlns:a="http://schemas.openxmlformats.org/drawingml/2006/main"/>
           <a:p xmlns:a="http://schemas.openxmlformats.org/drawingml/2006/main">
             <a:pPr algn="l">
+              <a:buNone/>
               <a:defRPr sz="863" b="0">
                 <a:solidFill>
                   <a:srgbClr val="17202A"/>
@@ -3119,6 +3137,7 @@
           <a:lstStyle xmlns:a="http://schemas.openxmlformats.org/drawingml/2006/main"/>
           <a:p xmlns:a="http://schemas.openxmlformats.org/drawingml/2006/main">
             <a:pPr algn="l">
+              <a:buNone/>
               <a:defRPr sz="1200" b="1">
                 <a:solidFill>
                   <a:srgbClr val="6559B7"/>
@@ -3183,6 +3202,7 @@
           <a:lstStyle xmlns:a="http://schemas.openxmlformats.org/drawingml/2006/main"/>
           <a:p xmlns:a="http://schemas.openxmlformats.org/drawingml/2006/main">
             <a:pPr algn="l">
+              <a:buNone/>
               <a:defRPr sz="863" b="0">
                 <a:solidFill>
                   <a:srgbClr val="17202A"/>
@@ -3280,6 +3300,7 @@
           <a:lstStyle xmlns:a="http://schemas.openxmlformats.org/drawingml/2006/main"/>
           <a:p xmlns:a="http://schemas.openxmlformats.org/drawingml/2006/main">
             <a:pPr algn="l">
+              <a:buNone/>
               <a:defRPr sz="1200" b="1">
                 <a:solidFill>
                   <a:srgbClr val="C85847"/>
@@ -3344,6 +3365,7 @@
           <a:lstStyle xmlns:a="http://schemas.openxmlformats.org/drawingml/2006/main"/>
           <a:p xmlns:a="http://schemas.openxmlformats.org/drawingml/2006/main">
             <a:pPr algn="l">
+              <a:buNone/>
               <a:defRPr sz="863" b="0">
                 <a:solidFill>
                   <a:srgbClr val="17202A"/>
@@ -3408,6 +3430,7 @@
           <a:lstStyle xmlns:a="http://schemas.openxmlformats.org/drawingml/2006/main"/>
           <a:p xmlns:a="http://schemas.openxmlformats.org/drawingml/2006/main">
             <a:pPr algn="l">
+              <a:buNone/>
               <a:defRPr sz="1350" b="0">
                 <a:solidFill>
                   <a:srgbClr val="D7E2DD"/>
@@ -3472,6 +3495,7 @@
           <a:lstStyle xmlns:a="http://schemas.openxmlformats.org/drawingml/2006/main"/>
           <a:p xmlns:a="http://schemas.openxmlformats.org/drawingml/2006/main">
             <a:pPr algn="r">
+              <a:buNone/>
               <a:defRPr sz="750" b="0">
                 <a:solidFill>
                   <a:srgbClr val="5F6B64"/>
@@ -3495,6 +3519,28 @@
           </a:p>
         </p:txBody>
       </p:sp>
+      <p:pic>
+        <p:nvPicPr>
+          <p:cNvPr id="40" name=""/>
+          <p:cNvPicPr>
+            <a:picLocks xmlns:a="http://schemas.openxmlformats.org/drawingml/2006/main" noChangeAspect="1"/>
+          </p:cNvPicPr>
+          <p:nvPr/>
+        </p:nvPicPr>
+        <p:blipFill>
+          <a:blip xmlns:r="http://schemas.openxmlformats.org/officeDocument/2006/relationships" xmlns:a="http://schemas.openxmlformats.org/drawingml/2006/main" r:embed="R53d4f7b6782b4c68"/>
+          <a:stretch xmlns:a="http://schemas.openxmlformats.org/drawingml/2006/main"/>
+        </p:blipFill>
+        <p:spPr>
+          <a:xfrm xmlns:a="http://schemas.openxmlformats.org/drawingml/2006/main">
+            <a:off x="9399495" y="266700"/>
+            <a:ext cx="1679760" cy="1047750"/>
+          </a:xfrm>
+          <a:prstGeom xmlns:a="http://schemas.openxmlformats.org/drawingml/2006/main" prst="rect">
+            <a:avLst/>
+          </a:prstGeom>
+        </p:spPr>
+      </p:pic>
     </p:spTree>
     <p:extLst>
       <p:ext uri="{BB962C8B-B14F-4D97-AF65-F5344CB8AC3E}">
@@ -3628,6 +3674,7 @@
           <a:lstStyle xmlns:a="http://schemas.openxmlformats.org/drawingml/2006/main"/>
           <a:p xmlns:a="http://schemas.openxmlformats.org/drawingml/2006/main">
             <a:pPr algn="l">
+              <a:buNone/>
               <a:defRPr sz="900" b="1">
                 <a:solidFill>
                   <a:srgbClr val="8DE0C7"/>
@@ -3692,6 +3739,7 @@
           <a:lstStyle xmlns:a="http://schemas.openxmlformats.org/drawingml/2006/main"/>
           <a:p xmlns:a="http://schemas.openxmlformats.org/drawingml/2006/main">
             <a:pPr algn="l">
+              <a:buNone/>
               <a:defRPr sz="2325" b="1">
                 <a:solidFill>
                   <a:srgbClr val="FFFFFF"/>
@@ -3789,6 +3837,7 @@
           <a:lstStyle xmlns:a="http://schemas.openxmlformats.org/drawingml/2006/main"/>
           <a:p xmlns:a="http://schemas.openxmlformats.org/drawingml/2006/main">
             <a:pPr algn="l">
+              <a:buNone/>
               <a:defRPr sz="1200" b="1">
                 <a:solidFill>
                   <a:srgbClr val="0F8A6A"/>
@@ -3853,6 +3902,7 @@
           <a:lstStyle xmlns:a="http://schemas.openxmlformats.org/drawingml/2006/main"/>
           <a:p xmlns:a="http://schemas.openxmlformats.org/drawingml/2006/main">
             <a:pPr algn="l">
+              <a:buNone/>
               <a:defRPr sz="863" b="0">
                 <a:solidFill>
                   <a:srgbClr val="17202A"/>
@@ -3950,6 +4000,7 @@
           <a:lstStyle xmlns:a="http://schemas.openxmlformats.org/drawingml/2006/main"/>
           <a:p xmlns:a="http://schemas.openxmlformats.org/drawingml/2006/main">
             <a:pPr algn="l">
+              <a:buNone/>
               <a:defRPr sz="1200" b="1">
                 <a:solidFill>
                   <a:srgbClr val="2E5EA7"/>
@@ -4014,6 +4065,7 @@
           <a:lstStyle xmlns:a="http://schemas.openxmlformats.org/drawingml/2006/main"/>
           <a:p xmlns:a="http://schemas.openxmlformats.org/drawingml/2006/main">
             <a:pPr algn="l">
+              <a:buNone/>
               <a:defRPr sz="863" b="0">
                 <a:solidFill>
                   <a:srgbClr val="17202A"/>
@@ -4111,6 +4163,7 @@
           <a:lstStyle xmlns:a="http://schemas.openxmlformats.org/drawingml/2006/main"/>
           <a:p xmlns:a="http://schemas.openxmlformats.org/drawingml/2006/main">
             <a:pPr algn="l">
+              <a:buNone/>
               <a:defRPr sz="1200" b="1">
                 <a:solidFill>
                   <a:srgbClr val="C98A21"/>
@@ -4175,6 +4228,7 @@
           <a:lstStyle xmlns:a="http://schemas.openxmlformats.org/drawingml/2006/main"/>
           <a:p xmlns:a="http://schemas.openxmlformats.org/drawingml/2006/main">
             <a:pPr algn="l">
+              <a:buNone/>
               <a:defRPr sz="863" b="0">
                 <a:solidFill>
                   <a:srgbClr val="17202A"/>
@@ -4272,6 +4326,7 @@
           <a:lstStyle xmlns:a="http://schemas.openxmlformats.org/drawingml/2006/main"/>
           <a:p xmlns:a="http://schemas.openxmlformats.org/drawingml/2006/main">
             <a:pPr algn="l">
+              <a:buNone/>
               <a:defRPr sz="1200" b="1">
                 <a:solidFill>
                   <a:srgbClr val="6559B7"/>
@@ -4336,6 +4391,7 @@
           <a:lstStyle xmlns:a="http://schemas.openxmlformats.org/drawingml/2006/main"/>
           <a:p xmlns:a="http://schemas.openxmlformats.org/drawingml/2006/main">
             <a:pPr algn="l">
+              <a:buNone/>
               <a:defRPr sz="863" b="0">
                 <a:solidFill>
                   <a:srgbClr val="17202A"/>
@@ -4433,6 +4489,7 @@
           <a:lstStyle xmlns:a="http://schemas.openxmlformats.org/drawingml/2006/main"/>
           <a:p xmlns:a="http://schemas.openxmlformats.org/drawingml/2006/main">
             <a:pPr algn="l">
+              <a:buNone/>
               <a:defRPr sz="1200" b="1">
                 <a:solidFill>
                   <a:srgbClr val="C85847"/>
@@ -4497,6 +4554,7 @@
           <a:lstStyle xmlns:a="http://schemas.openxmlformats.org/drawingml/2006/main"/>
           <a:p xmlns:a="http://schemas.openxmlformats.org/drawingml/2006/main">
             <a:pPr algn="l">
+              <a:buNone/>
               <a:defRPr sz="863" b="0">
                 <a:solidFill>
                   <a:srgbClr val="17202A"/>
@@ -4825,6 +4883,7 @@
           <a:lstStyle xmlns:a="http://schemas.openxmlformats.org/drawingml/2006/main"/>
           <a:p xmlns:a="http://schemas.openxmlformats.org/drawingml/2006/main">
             <a:pPr algn="l">
+              <a:buNone/>
               <a:defRPr sz="2250" b="1">
                 <a:solidFill>
                   <a:srgbClr val="FFFFFF"/>
@@ -4889,6 +4948,7 @@
           <a:lstStyle xmlns:a="http://schemas.openxmlformats.org/drawingml/2006/main"/>
           <a:p xmlns:a="http://schemas.openxmlformats.org/drawingml/2006/main">
             <a:pPr algn="l">
+              <a:buNone/>
               <a:defRPr sz="1500" b="0">
                 <a:solidFill>
                   <a:srgbClr val="D7E2DD"/>
@@ -4953,6 +5013,7 @@
           <a:lstStyle xmlns:a="http://schemas.openxmlformats.org/drawingml/2006/main"/>
           <a:p xmlns:a="http://schemas.openxmlformats.org/drawingml/2006/main">
             <a:pPr algn="l">
+              <a:buNone/>
               <a:defRPr sz="900" b="0">
                 <a:solidFill>
                   <a:srgbClr val="8DE0C7"/>
@@ -5017,6 +5078,7 @@
           <a:lstStyle xmlns:a="http://schemas.openxmlformats.org/drawingml/2006/main"/>
           <a:p xmlns:a="http://schemas.openxmlformats.org/drawingml/2006/main">
             <a:pPr algn="r">
+              <a:buNone/>
               <a:defRPr sz="750" b="0">
                 <a:solidFill>
                   <a:srgbClr val="5F6B64"/>
@@ -5040,6 +5102,28 @@
           </a:p>
         </p:txBody>
       </p:sp>
+      <p:pic>
+        <p:nvPicPr>
+          <p:cNvPr id="32" name=""/>
+          <p:cNvPicPr>
+            <a:picLocks xmlns:a="http://schemas.openxmlformats.org/drawingml/2006/main" noChangeAspect="1"/>
+          </p:cNvPicPr>
+          <p:nvPr/>
+        </p:nvPicPr>
+        <p:blipFill>
+          <a:blip xmlns:r="http://schemas.openxmlformats.org/officeDocument/2006/relationships" xmlns:a="http://schemas.openxmlformats.org/drawingml/2006/main" r:embed="Rb154235000424b0a"/>
+          <a:stretch xmlns:a="http://schemas.openxmlformats.org/drawingml/2006/main"/>
+        </p:blipFill>
+        <p:spPr>
+          <a:xfrm xmlns:a="http://schemas.openxmlformats.org/drawingml/2006/main">
+            <a:off x="8766913" y="4476750"/>
+            <a:ext cx="1801924" cy="1123950"/>
+          </a:xfrm>
+          <a:prstGeom xmlns:a="http://schemas.openxmlformats.org/drawingml/2006/main" prst="rect">
+            <a:avLst/>
+          </a:prstGeom>
+        </p:spPr>
+      </p:pic>
     </p:spTree>
     <p:extLst>
       <p:ext uri="{BB962C8B-B14F-4D97-AF65-F5344CB8AC3E}">
@@ -5173,6 +5257,7 @@
           <a:lstStyle xmlns:a="http://schemas.openxmlformats.org/drawingml/2006/main"/>
           <a:p xmlns:a="http://schemas.openxmlformats.org/drawingml/2006/main">
             <a:pPr algn="l">
+              <a:buNone/>
               <a:defRPr sz="900" b="1">
                 <a:solidFill>
                   <a:srgbClr val="0F8A6A"/>
@@ -5237,6 +5322,7 @@
           <a:lstStyle xmlns:a="http://schemas.openxmlformats.org/drawingml/2006/main"/>
           <a:p xmlns:a="http://schemas.openxmlformats.org/drawingml/2006/main">
             <a:pPr algn="l">
+              <a:buNone/>
               <a:defRPr sz="2325" b="1">
                 <a:solidFill>
                   <a:srgbClr val="17202A"/>
@@ -5369,6 +5455,7 @@
           <a:lstStyle xmlns:a="http://schemas.openxmlformats.org/drawingml/2006/main"/>
           <a:p xmlns:a="http://schemas.openxmlformats.org/drawingml/2006/main">
             <a:pPr algn="l">
+              <a:buNone/>
               <a:defRPr sz="1275" b="1">
                 <a:solidFill>
                   <a:srgbClr val="17202A"/>
@@ -5433,6 +5520,7 @@
           <a:lstStyle xmlns:a="http://schemas.openxmlformats.org/drawingml/2006/main"/>
           <a:p xmlns:a="http://schemas.openxmlformats.org/drawingml/2006/main">
             <a:pPr algn="l">
+              <a:buNone/>
               <a:defRPr sz="938" b="0">
                 <a:solidFill>
                   <a:srgbClr val="5F6B64"/>
@@ -5565,6 +5653,7 @@
           <a:lstStyle xmlns:a="http://schemas.openxmlformats.org/drawingml/2006/main"/>
           <a:p xmlns:a="http://schemas.openxmlformats.org/drawingml/2006/main">
             <a:pPr algn="l">
+              <a:buNone/>
               <a:defRPr sz="1275" b="1">
                 <a:solidFill>
                   <a:srgbClr val="17202A"/>
@@ -5629,6 +5718,7 @@
           <a:lstStyle xmlns:a="http://schemas.openxmlformats.org/drawingml/2006/main"/>
           <a:p xmlns:a="http://schemas.openxmlformats.org/drawingml/2006/main">
             <a:pPr algn="l">
+              <a:buNone/>
               <a:defRPr sz="938" b="0">
                 <a:solidFill>
                   <a:srgbClr val="5F6B64"/>
@@ -5761,6 +5851,7 @@
           <a:lstStyle xmlns:a="http://schemas.openxmlformats.org/drawingml/2006/main"/>
           <a:p xmlns:a="http://schemas.openxmlformats.org/drawingml/2006/main">
             <a:pPr algn="l">
+              <a:buNone/>
               <a:defRPr sz="1275" b="1">
                 <a:solidFill>
                   <a:srgbClr val="17202A"/>
@@ -5825,6 +5916,7 @@
           <a:lstStyle xmlns:a="http://schemas.openxmlformats.org/drawingml/2006/main"/>
           <a:p xmlns:a="http://schemas.openxmlformats.org/drawingml/2006/main">
             <a:pPr algn="l">
+              <a:buNone/>
               <a:defRPr sz="938" b="0">
                 <a:solidFill>
                   <a:srgbClr val="5F6B64"/>
@@ -5922,6 +6014,7 @@
           <a:lstStyle xmlns:a="http://schemas.openxmlformats.org/drawingml/2006/main"/>
           <a:p xmlns:a="http://schemas.openxmlformats.org/drawingml/2006/main">
             <a:pPr algn="ctr">
+              <a:buNone/>
               <a:defRPr sz="1350" b="0">
                 <a:solidFill>
                   <a:srgbClr val="5F6B64"/>
@@ -5986,6 +6079,7 @@
           <a:lstStyle xmlns:a="http://schemas.openxmlformats.org/drawingml/2006/main"/>
           <a:p xmlns:a="http://schemas.openxmlformats.org/drawingml/2006/main">
             <a:pPr algn="ctr">
+              <a:buNone/>
               <a:defRPr sz="1725" b="1">
                 <a:solidFill>
                   <a:srgbClr val="17202A"/>
@@ -6050,6 +6144,7 @@
           <a:lstStyle xmlns:a="http://schemas.openxmlformats.org/drawingml/2006/main"/>
           <a:p xmlns:a="http://schemas.openxmlformats.org/drawingml/2006/main">
             <a:pPr algn="r">
+              <a:buNone/>
               <a:defRPr sz="750" b="0">
                 <a:solidFill>
                   <a:srgbClr val="5F6B64"/>
@@ -6206,6 +6301,7 @@
           <a:lstStyle xmlns:a="http://schemas.openxmlformats.org/drawingml/2006/main"/>
           <a:p xmlns:a="http://schemas.openxmlformats.org/drawingml/2006/main">
             <a:pPr algn="l">
+              <a:buNone/>
               <a:defRPr sz="900" b="1">
                 <a:solidFill>
                   <a:srgbClr val="0F8A6A"/>
@@ -6270,6 +6366,7 @@
           <a:lstStyle xmlns:a="http://schemas.openxmlformats.org/drawingml/2006/main"/>
           <a:p xmlns:a="http://schemas.openxmlformats.org/drawingml/2006/main">
             <a:pPr algn="l">
+              <a:buNone/>
               <a:defRPr sz="2325" b="1">
                 <a:solidFill>
                   <a:srgbClr val="17202A"/>
@@ -6367,6 +6464,7 @@
           <a:lstStyle xmlns:a="http://schemas.openxmlformats.org/drawingml/2006/main"/>
           <a:p xmlns:a="http://schemas.openxmlformats.org/drawingml/2006/main">
             <a:pPr algn="ctr">
+              <a:buNone/>
               <a:defRPr sz="788" b="1">
                 <a:solidFill>
                   <a:srgbClr val="0F8A6A"/>
@@ -6464,6 +6562,7 @@
           <a:lstStyle xmlns:a="http://schemas.openxmlformats.org/drawingml/2006/main"/>
           <a:p xmlns:a="http://schemas.openxmlformats.org/drawingml/2006/main">
             <a:pPr algn="l">
+              <a:buNone/>
               <a:defRPr sz="1200" b="1">
                 <a:solidFill>
                   <a:srgbClr val="0F8A6A"/>
@@ -6528,6 +6627,7 @@
           <a:lstStyle xmlns:a="http://schemas.openxmlformats.org/drawingml/2006/main"/>
           <a:p xmlns:a="http://schemas.openxmlformats.org/drawingml/2006/main">
             <a:pPr algn="l">
+              <a:buNone/>
               <a:defRPr sz="863" b="0">
                 <a:solidFill>
                   <a:srgbClr val="17202A"/>
@@ -6625,6 +6725,7 @@
           <a:lstStyle xmlns:a="http://schemas.openxmlformats.org/drawingml/2006/main"/>
           <a:p xmlns:a="http://schemas.openxmlformats.org/drawingml/2006/main">
             <a:pPr algn="ctr">
+              <a:buNone/>
               <a:defRPr sz="788" b="1">
                 <a:solidFill>
                   <a:srgbClr val="2E5EA7"/>
@@ -6722,6 +6823,7 @@
           <a:lstStyle xmlns:a="http://schemas.openxmlformats.org/drawingml/2006/main"/>
           <a:p xmlns:a="http://schemas.openxmlformats.org/drawingml/2006/main">
             <a:pPr algn="l">
+              <a:buNone/>
               <a:defRPr sz="1200" b="1">
                 <a:solidFill>
                   <a:srgbClr val="2E5EA7"/>
@@ -6786,6 +6888,7 @@
           <a:lstStyle xmlns:a="http://schemas.openxmlformats.org/drawingml/2006/main"/>
           <a:p xmlns:a="http://schemas.openxmlformats.org/drawingml/2006/main">
             <a:pPr algn="l">
+              <a:buNone/>
               <a:defRPr sz="863" b="0">
                 <a:solidFill>
                   <a:srgbClr val="17202A"/>
@@ -6883,6 +6986,7 @@
           <a:lstStyle xmlns:a="http://schemas.openxmlformats.org/drawingml/2006/main"/>
           <a:p xmlns:a="http://schemas.openxmlformats.org/drawingml/2006/main">
             <a:pPr algn="ctr">
+              <a:buNone/>
               <a:defRPr sz="788" b="1">
                 <a:solidFill>
                   <a:srgbClr val="C98A21"/>
@@ -6980,6 +7084,7 @@
           <a:lstStyle xmlns:a="http://schemas.openxmlformats.org/drawingml/2006/main"/>
           <a:p xmlns:a="http://schemas.openxmlformats.org/drawingml/2006/main">
             <a:pPr algn="l">
+              <a:buNone/>
               <a:defRPr sz="1200" b="1">
                 <a:solidFill>
                   <a:srgbClr val="C98A21"/>
@@ -7044,6 +7149,7 @@
           <a:lstStyle xmlns:a="http://schemas.openxmlformats.org/drawingml/2006/main"/>
           <a:p xmlns:a="http://schemas.openxmlformats.org/drawingml/2006/main">
             <a:pPr algn="l">
+              <a:buNone/>
               <a:defRPr sz="863" b="0">
                 <a:solidFill>
                   <a:srgbClr val="17202A"/>
@@ -7141,6 +7247,7 @@
           <a:lstStyle xmlns:a="http://schemas.openxmlformats.org/drawingml/2006/main"/>
           <a:p xmlns:a="http://schemas.openxmlformats.org/drawingml/2006/main">
             <a:pPr algn="ctr">
+              <a:buNone/>
               <a:defRPr sz="788" b="1">
                 <a:solidFill>
                   <a:srgbClr val="6559B7"/>
@@ -7238,6 +7345,7 @@
           <a:lstStyle xmlns:a="http://schemas.openxmlformats.org/drawingml/2006/main"/>
           <a:p xmlns:a="http://schemas.openxmlformats.org/drawingml/2006/main">
             <a:pPr algn="l">
+              <a:buNone/>
               <a:defRPr sz="1200" b="1">
                 <a:solidFill>
                   <a:srgbClr val="6559B7"/>
@@ -7302,6 +7410,7 @@
           <a:lstStyle xmlns:a="http://schemas.openxmlformats.org/drawingml/2006/main"/>
           <a:p xmlns:a="http://schemas.openxmlformats.org/drawingml/2006/main">
             <a:pPr algn="l">
+              <a:buNone/>
               <a:defRPr sz="863" b="0">
                 <a:solidFill>
                   <a:srgbClr val="17202A"/>
@@ -7399,6 +7508,7 @@
           <a:lstStyle xmlns:a="http://schemas.openxmlformats.org/drawingml/2006/main"/>
           <a:p xmlns:a="http://schemas.openxmlformats.org/drawingml/2006/main">
             <a:pPr algn="l">
+              <a:buNone/>
               <a:defRPr sz="1200" b="1">
                 <a:solidFill>
                   <a:srgbClr val="C85847"/>
@@ -7463,6 +7573,7 @@
           <a:lstStyle xmlns:a="http://schemas.openxmlformats.org/drawingml/2006/main"/>
           <a:p xmlns:a="http://schemas.openxmlformats.org/drawingml/2006/main">
             <a:pPr algn="l">
+              <a:buNone/>
               <a:defRPr sz="863" b="0">
                 <a:solidFill>
                   <a:srgbClr val="17202A"/>
@@ -7593,6 +7704,7 @@
           <a:lstStyle xmlns:a="http://schemas.openxmlformats.org/drawingml/2006/main"/>
           <a:p xmlns:a="http://schemas.openxmlformats.org/drawingml/2006/main">
             <a:pPr algn="r">
+              <a:buNone/>
               <a:defRPr sz="750" b="0">
                 <a:solidFill>
                   <a:srgbClr val="5F6B64"/>
@@ -7749,6 +7861,7 @@
           <a:lstStyle xmlns:a="http://schemas.openxmlformats.org/drawingml/2006/main"/>
           <a:p xmlns:a="http://schemas.openxmlformats.org/drawingml/2006/main">
             <a:pPr algn="l">
+              <a:buNone/>
               <a:defRPr sz="900" b="1">
                 <a:solidFill>
                   <a:srgbClr val="0F8A6A"/>
@@ -7813,6 +7926,7 @@
           <a:lstStyle xmlns:a="http://schemas.openxmlformats.org/drawingml/2006/main"/>
           <a:p xmlns:a="http://schemas.openxmlformats.org/drawingml/2006/main">
             <a:pPr algn="l">
+              <a:buNone/>
               <a:defRPr sz="2325" b="1">
                 <a:solidFill>
                   <a:srgbClr val="17202A"/>
@@ -7910,6 +8024,7 @@
           <a:lstStyle xmlns:a="http://schemas.openxmlformats.org/drawingml/2006/main"/>
           <a:p xmlns:a="http://schemas.openxmlformats.org/drawingml/2006/main">
             <a:pPr algn="ctr">
+              <a:buNone/>
               <a:defRPr sz="788" b="1">
                 <a:solidFill>
                   <a:srgbClr val="0F8A6A"/>
@@ -8007,6 +8122,7 @@
           <a:lstStyle xmlns:a="http://schemas.openxmlformats.org/drawingml/2006/main"/>
           <a:p xmlns:a="http://schemas.openxmlformats.org/drawingml/2006/main">
             <a:pPr algn="l">
+              <a:buNone/>
               <a:defRPr sz="900" b="1">
                 <a:solidFill>
                   <a:srgbClr val="FFFFFF"/>
@@ -8104,6 +8220,7 @@
           <a:lstStyle xmlns:a="http://schemas.openxmlformats.org/drawingml/2006/main"/>
           <a:p xmlns:a="http://schemas.openxmlformats.org/drawingml/2006/main">
             <a:pPr algn="l">
+              <a:buNone/>
               <a:defRPr sz="900" b="1">
                 <a:solidFill>
                   <a:srgbClr val="FFFFFF"/>
@@ -8201,6 +8318,7 @@
           <a:lstStyle xmlns:a="http://schemas.openxmlformats.org/drawingml/2006/main"/>
           <a:p xmlns:a="http://schemas.openxmlformats.org/drawingml/2006/main">
             <a:pPr algn="l">
+              <a:buNone/>
               <a:defRPr sz="900" b="1">
                 <a:solidFill>
                   <a:srgbClr val="FFFFFF"/>
@@ -8298,6 +8416,7 @@
           <a:lstStyle xmlns:a="http://schemas.openxmlformats.org/drawingml/2006/main"/>
           <a:p xmlns:a="http://schemas.openxmlformats.org/drawingml/2006/main">
             <a:pPr algn="l">
+              <a:buNone/>
               <a:defRPr sz="900" b="1">
                 <a:solidFill>
                   <a:srgbClr val="FFFFFF"/>
@@ -8395,6 +8514,7 @@
           <a:lstStyle xmlns:a="http://schemas.openxmlformats.org/drawingml/2006/main"/>
           <a:p xmlns:a="http://schemas.openxmlformats.org/drawingml/2006/main">
             <a:pPr algn="l">
+              <a:buNone/>
               <a:defRPr sz="825" b="0">
                 <a:solidFill>
                   <a:srgbClr val="17202A"/>
@@ -8492,6 +8612,7 @@
           <a:lstStyle xmlns:a="http://schemas.openxmlformats.org/drawingml/2006/main"/>
           <a:p xmlns:a="http://schemas.openxmlformats.org/drawingml/2006/main">
             <a:pPr algn="l">
+              <a:buNone/>
               <a:defRPr sz="863" b="1">
                 <a:solidFill>
                   <a:srgbClr val="0F8A6A"/>
@@ -8589,6 +8710,7 @@
           <a:lstStyle xmlns:a="http://schemas.openxmlformats.org/drawingml/2006/main"/>
           <a:p xmlns:a="http://schemas.openxmlformats.org/drawingml/2006/main">
             <a:pPr algn="l">
+              <a:buNone/>
               <a:defRPr sz="863" b="0">
                 <a:solidFill>
                   <a:srgbClr val="17202A"/>
@@ -8686,6 +8808,7 @@
           <a:lstStyle xmlns:a="http://schemas.openxmlformats.org/drawingml/2006/main"/>
           <a:p xmlns:a="http://schemas.openxmlformats.org/drawingml/2006/main">
             <a:pPr algn="l">
+              <a:buNone/>
               <a:defRPr sz="863" b="0">
                 <a:solidFill>
                   <a:srgbClr val="17202A"/>
@@ -8783,6 +8906,7 @@
           <a:lstStyle xmlns:a="http://schemas.openxmlformats.org/drawingml/2006/main"/>
           <a:p xmlns:a="http://schemas.openxmlformats.org/drawingml/2006/main">
             <a:pPr algn="l">
+              <a:buNone/>
               <a:defRPr sz="825" b="0">
                 <a:solidFill>
                   <a:srgbClr val="17202A"/>
@@ -8880,6 +9004,7 @@
           <a:lstStyle xmlns:a="http://schemas.openxmlformats.org/drawingml/2006/main"/>
           <a:p xmlns:a="http://schemas.openxmlformats.org/drawingml/2006/main">
             <a:pPr algn="l">
+              <a:buNone/>
               <a:defRPr sz="863" b="1">
                 <a:solidFill>
                   <a:srgbClr val="0F8A6A"/>
@@ -8977,6 +9102,7 @@
           <a:lstStyle xmlns:a="http://schemas.openxmlformats.org/drawingml/2006/main"/>
           <a:p xmlns:a="http://schemas.openxmlformats.org/drawingml/2006/main">
             <a:pPr algn="l">
+              <a:buNone/>
               <a:defRPr sz="863" b="0">
                 <a:solidFill>
                   <a:srgbClr val="17202A"/>
@@ -9074,6 +9200,7 @@
           <a:lstStyle xmlns:a="http://schemas.openxmlformats.org/drawingml/2006/main"/>
           <a:p xmlns:a="http://schemas.openxmlformats.org/drawingml/2006/main">
             <a:pPr algn="l">
+              <a:buNone/>
               <a:defRPr sz="863" b="0">
                 <a:solidFill>
                   <a:srgbClr val="17202A"/>
@@ -9171,6 +9298,7 @@
           <a:lstStyle xmlns:a="http://schemas.openxmlformats.org/drawingml/2006/main"/>
           <a:p xmlns:a="http://schemas.openxmlformats.org/drawingml/2006/main">
             <a:pPr algn="l">
+              <a:buNone/>
               <a:defRPr sz="825" b="0">
                 <a:solidFill>
                   <a:srgbClr val="17202A"/>
@@ -9268,6 +9396,7 @@
           <a:lstStyle xmlns:a="http://schemas.openxmlformats.org/drawingml/2006/main"/>
           <a:p xmlns:a="http://schemas.openxmlformats.org/drawingml/2006/main">
             <a:pPr algn="l">
+              <a:buNone/>
               <a:defRPr sz="863" b="1">
                 <a:solidFill>
                   <a:srgbClr val="0F8A6A"/>
@@ -9365,6 +9494,7 @@
           <a:lstStyle xmlns:a="http://schemas.openxmlformats.org/drawingml/2006/main"/>
           <a:p xmlns:a="http://schemas.openxmlformats.org/drawingml/2006/main">
             <a:pPr algn="l">
+              <a:buNone/>
               <a:defRPr sz="863" b="0">
                 <a:solidFill>
                   <a:srgbClr val="17202A"/>
@@ -9462,6 +9592,7 @@
           <a:lstStyle xmlns:a="http://schemas.openxmlformats.org/drawingml/2006/main"/>
           <a:p xmlns:a="http://schemas.openxmlformats.org/drawingml/2006/main">
             <a:pPr algn="l">
+              <a:buNone/>
               <a:defRPr sz="863" b="0">
                 <a:solidFill>
                   <a:srgbClr val="17202A"/>
@@ -9559,6 +9690,7 @@
           <a:lstStyle xmlns:a="http://schemas.openxmlformats.org/drawingml/2006/main"/>
           <a:p xmlns:a="http://schemas.openxmlformats.org/drawingml/2006/main">
             <a:pPr algn="l">
+              <a:buNone/>
               <a:defRPr sz="825" b="0">
                 <a:solidFill>
                   <a:srgbClr val="17202A"/>
@@ -9656,6 +9788,7 @@
           <a:lstStyle xmlns:a="http://schemas.openxmlformats.org/drawingml/2006/main"/>
           <a:p xmlns:a="http://schemas.openxmlformats.org/drawingml/2006/main">
             <a:pPr algn="l">
+              <a:buNone/>
               <a:defRPr sz="863" b="1">
                 <a:solidFill>
                   <a:srgbClr val="0F8A6A"/>
@@ -9753,6 +9886,7 @@
           <a:lstStyle xmlns:a="http://schemas.openxmlformats.org/drawingml/2006/main"/>
           <a:p xmlns:a="http://schemas.openxmlformats.org/drawingml/2006/main">
             <a:pPr algn="l">
+              <a:buNone/>
               <a:defRPr sz="863" b="0">
                 <a:solidFill>
                   <a:srgbClr val="17202A"/>
@@ -9850,6 +9984,7 @@
           <a:lstStyle xmlns:a="http://schemas.openxmlformats.org/drawingml/2006/main"/>
           <a:p xmlns:a="http://schemas.openxmlformats.org/drawingml/2006/main">
             <a:pPr algn="l">
+              <a:buNone/>
               <a:defRPr sz="863" b="0">
                 <a:solidFill>
                   <a:srgbClr val="17202A"/>
@@ -9947,6 +10082,7 @@
           <a:lstStyle xmlns:a="http://schemas.openxmlformats.org/drawingml/2006/main"/>
           <a:p xmlns:a="http://schemas.openxmlformats.org/drawingml/2006/main">
             <a:pPr algn="l">
+              <a:buNone/>
               <a:defRPr sz="825" b="0">
                 <a:solidFill>
                   <a:srgbClr val="17202A"/>
@@ -10044,6 +10180,7 @@
           <a:lstStyle xmlns:a="http://schemas.openxmlformats.org/drawingml/2006/main"/>
           <a:p xmlns:a="http://schemas.openxmlformats.org/drawingml/2006/main">
             <a:pPr algn="l">
+              <a:buNone/>
               <a:defRPr sz="863" b="1">
                 <a:solidFill>
                   <a:srgbClr val="0F8A6A"/>
@@ -10141,6 +10278,7 @@
           <a:lstStyle xmlns:a="http://schemas.openxmlformats.org/drawingml/2006/main"/>
           <a:p xmlns:a="http://schemas.openxmlformats.org/drawingml/2006/main">
             <a:pPr algn="l">
+              <a:buNone/>
               <a:defRPr sz="863" b="0">
                 <a:solidFill>
                   <a:srgbClr val="17202A"/>
@@ -10238,6 +10376,7 @@
           <a:lstStyle xmlns:a="http://schemas.openxmlformats.org/drawingml/2006/main"/>
           <a:p xmlns:a="http://schemas.openxmlformats.org/drawingml/2006/main">
             <a:pPr algn="l">
+              <a:buNone/>
               <a:defRPr sz="863" b="0">
                 <a:solidFill>
                   <a:srgbClr val="17202A"/>
@@ -10335,6 +10474,7 @@
           <a:lstStyle xmlns:a="http://schemas.openxmlformats.org/drawingml/2006/main"/>
           <a:p xmlns:a="http://schemas.openxmlformats.org/drawingml/2006/main">
             <a:pPr algn="l">
+              <a:buNone/>
               <a:defRPr sz="825" b="0">
                 <a:solidFill>
                   <a:srgbClr val="17202A"/>
@@ -10432,6 +10572,7 @@
           <a:lstStyle xmlns:a="http://schemas.openxmlformats.org/drawingml/2006/main"/>
           <a:p xmlns:a="http://schemas.openxmlformats.org/drawingml/2006/main">
             <a:pPr algn="l">
+              <a:buNone/>
               <a:defRPr sz="863" b="1">
                 <a:solidFill>
                   <a:srgbClr val="0F8A6A"/>
@@ -10529,6 +10670,7 @@
           <a:lstStyle xmlns:a="http://schemas.openxmlformats.org/drawingml/2006/main"/>
           <a:p xmlns:a="http://schemas.openxmlformats.org/drawingml/2006/main">
             <a:pPr algn="l">
+              <a:buNone/>
               <a:defRPr sz="863" b="0">
                 <a:solidFill>
                   <a:srgbClr val="17202A"/>
@@ -10626,6 +10768,7 @@
           <a:lstStyle xmlns:a="http://schemas.openxmlformats.org/drawingml/2006/main"/>
           <a:p xmlns:a="http://schemas.openxmlformats.org/drawingml/2006/main">
             <a:pPr algn="l">
+              <a:buNone/>
               <a:defRPr sz="863" b="0">
                 <a:solidFill>
                   <a:srgbClr val="17202A"/>
@@ -10690,6 +10833,7 @@
           <a:lstStyle xmlns:a="http://schemas.openxmlformats.org/drawingml/2006/main"/>
           <a:p xmlns:a="http://schemas.openxmlformats.org/drawingml/2006/main">
             <a:pPr algn="ctr">
+              <a:buNone/>
               <a:defRPr sz="1050" b="0">
                 <a:solidFill>
                   <a:srgbClr val="5F6B64"/>
@@ -10754,6 +10898,7 @@
           <a:lstStyle xmlns:a="http://schemas.openxmlformats.org/drawingml/2006/main"/>
           <a:p xmlns:a="http://schemas.openxmlformats.org/drawingml/2006/main">
             <a:pPr algn="r">
+              <a:buNone/>
               <a:defRPr sz="750" b="0">
                 <a:solidFill>
                   <a:srgbClr val="5F6B64"/>
@@ -10910,6 +11055,7 @@
           <a:lstStyle xmlns:a="http://schemas.openxmlformats.org/drawingml/2006/main"/>
           <a:p xmlns:a="http://schemas.openxmlformats.org/drawingml/2006/main">
             <a:pPr algn="l">
+              <a:buNone/>
               <a:defRPr sz="900" b="1">
                 <a:solidFill>
                   <a:srgbClr val="0F8A6A"/>
@@ -10974,6 +11120,7 @@
           <a:lstStyle xmlns:a="http://schemas.openxmlformats.org/drawingml/2006/main"/>
           <a:p xmlns:a="http://schemas.openxmlformats.org/drawingml/2006/main">
             <a:pPr algn="l">
+              <a:buNone/>
               <a:defRPr sz="2325" b="1">
                 <a:solidFill>
                   <a:srgbClr val="17202A"/>
@@ -11071,6 +11218,7 @@
           <a:lstStyle xmlns:a="http://schemas.openxmlformats.org/drawingml/2006/main"/>
           <a:p xmlns:a="http://schemas.openxmlformats.org/drawingml/2006/main">
             <a:pPr algn="l">
+              <a:buNone/>
               <a:defRPr sz="1200" b="1">
                 <a:solidFill>
                   <a:srgbClr val="0F8A6A"/>
@@ -11135,6 +11283,7 @@
           <a:lstStyle xmlns:a="http://schemas.openxmlformats.org/drawingml/2006/main"/>
           <a:p xmlns:a="http://schemas.openxmlformats.org/drawingml/2006/main">
             <a:pPr algn="l">
+              <a:buNone/>
               <a:defRPr sz="863" b="0">
                 <a:solidFill>
                   <a:srgbClr val="17202A"/>
@@ -11232,6 +11381,7 @@
           <a:lstStyle xmlns:a="http://schemas.openxmlformats.org/drawingml/2006/main"/>
           <a:p xmlns:a="http://schemas.openxmlformats.org/drawingml/2006/main">
             <a:pPr algn="l">
+              <a:buNone/>
               <a:defRPr sz="1200" b="1">
                 <a:solidFill>
                   <a:srgbClr val="2E5EA7"/>
@@ -11296,6 +11446,7 @@
           <a:lstStyle xmlns:a="http://schemas.openxmlformats.org/drawingml/2006/main"/>
           <a:p xmlns:a="http://schemas.openxmlformats.org/drawingml/2006/main">
             <a:pPr algn="l">
+              <a:buNone/>
               <a:defRPr sz="863" b="0">
                 <a:solidFill>
                   <a:srgbClr val="17202A"/>
@@ -11393,6 +11544,7 @@
           <a:lstStyle xmlns:a="http://schemas.openxmlformats.org/drawingml/2006/main"/>
           <a:p xmlns:a="http://schemas.openxmlformats.org/drawingml/2006/main">
             <a:pPr algn="l">
+              <a:buNone/>
               <a:defRPr sz="1200" b="1">
                 <a:solidFill>
                   <a:srgbClr val="6559B7"/>
@@ -11457,6 +11609,7 @@
           <a:lstStyle xmlns:a="http://schemas.openxmlformats.org/drawingml/2006/main"/>
           <a:p xmlns:a="http://schemas.openxmlformats.org/drawingml/2006/main">
             <a:pPr algn="l">
+              <a:buNone/>
               <a:defRPr sz="863" b="0">
                 <a:solidFill>
                   <a:srgbClr val="17202A"/>
@@ -11554,6 +11707,7 @@
           <a:lstStyle xmlns:a="http://schemas.openxmlformats.org/drawingml/2006/main"/>
           <a:p xmlns:a="http://schemas.openxmlformats.org/drawingml/2006/main">
             <a:pPr algn="l">
+              <a:buNone/>
               <a:defRPr sz="1200" b="1">
                 <a:solidFill>
                   <a:srgbClr val="C98A21"/>
@@ -11618,6 +11772,7 @@
           <a:lstStyle xmlns:a="http://schemas.openxmlformats.org/drawingml/2006/main"/>
           <a:p xmlns:a="http://schemas.openxmlformats.org/drawingml/2006/main">
             <a:pPr algn="l">
+              <a:buNone/>
               <a:defRPr sz="863" b="0">
                 <a:solidFill>
                   <a:srgbClr val="17202A"/>
@@ -11715,6 +11870,7 @@
           <a:lstStyle xmlns:a="http://schemas.openxmlformats.org/drawingml/2006/main"/>
           <a:p xmlns:a="http://schemas.openxmlformats.org/drawingml/2006/main">
             <a:pPr algn="l">
+              <a:buNone/>
               <a:defRPr sz="1200" b="1">
                 <a:solidFill>
                   <a:srgbClr val="C85847"/>
@@ -11779,6 +11935,7 @@
           <a:lstStyle xmlns:a="http://schemas.openxmlformats.org/drawingml/2006/main"/>
           <a:p xmlns:a="http://schemas.openxmlformats.org/drawingml/2006/main">
             <a:pPr algn="l">
+              <a:buNone/>
               <a:defRPr sz="863" b="0">
                 <a:solidFill>
                   <a:srgbClr val="17202A"/>
@@ -11876,6 +12033,7 @@
           <a:lstStyle xmlns:a="http://schemas.openxmlformats.org/drawingml/2006/main"/>
           <a:p xmlns:a="http://schemas.openxmlformats.org/drawingml/2006/main">
             <a:pPr algn="l">
+              <a:buNone/>
               <a:defRPr sz="1200" b="1">
                 <a:solidFill>
                   <a:srgbClr val="0F8A6A"/>
@@ -11940,6 +12098,7 @@
           <a:lstStyle xmlns:a="http://schemas.openxmlformats.org/drawingml/2006/main"/>
           <a:p xmlns:a="http://schemas.openxmlformats.org/drawingml/2006/main">
             <a:pPr algn="l">
+              <a:buNone/>
               <a:defRPr sz="863" b="0">
                 <a:solidFill>
                   <a:srgbClr val="17202A"/>
@@ -12402,6 +12561,7 @@
           <a:lstStyle xmlns:a="http://schemas.openxmlformats.org/drawingml/2006/main"/>
           <a:p xmlns:a="http://schemas.openxmlformats.org/drawingml/2006/main">
             <a:pPr algn="l">
+              <a:buNone/>
               <a:defRPr sz="2100" b="1">
                 <a:solidFill>
                   <a:srgbClr val="17202A"/>
@@ -12466,6 +12626,7 @@
           <a:lstStyle xmlns:a="http://schemas.openxmlformats.org/drawingml/2006/main"/>
           <a:p xmlns:a="http://schemas.openxmlformats.org/drawingml/2006/main">
             <a:pPr algn="l">
+              <a:buNone/>
               <a:defRPr sz="900" b="0">
                 <a:solidFill>
                   <a:srgbClr val="5F6B64"/>
@@ -12598,6 +12759,7 @@
           <a:lstStyle xmlns:a="http://schemas.openxmlformats.org/drawingml/2006/main"/>
           <a:p xmlns:a="http://schemas.openxmlformats.org/drawingml/2006/main">
             <a:pPr algn="l">
+              <a:buNone/>
               <a:defRPr sz="2100" b="1">
                 <a:solidFill>
                   <a:srgbClr val="17202A"/>
@@ -12662,6 +12824,7 @@
           <a:lstStyle xmlns:a="http://schemas.openxmlformats.org/drawingml/2006/main"/>
           <a:p xmlns:a="http://schemas.openxmlformats.org/drawingml/2006/main">
             <a:pPr algn="l">
+              <a:buNone/>
               <a:defRPr sz="900" b="0">
                 <a:solidFill>
                   <a:srgbClr val="5F6B64"/>
@@ -12794,6 +12957,7 @@
           <a:lstStyle xmlns:a="http://schemas.openxmlformats.org/drawingml/2006/main"/>
           <a:p xmlns:a="http://schemas.openxmlformats.org/drawingml/2006/main">
             <a:pPr algn="l">
+              <a:buNone/>
               <a:defRPr sz="2100" b="1">
                 <a:solidFill>
                   <a:srgbClr val="17202A"/>
@@ -12858,6 +13022,7 @@
           <a:lstStyle xmlns:a="http://schemas.openxmlformats.org/drawingml/2006/main"/>
           <a:p xmlns:a="http://schemas.openxmlformats.org/drawingml/2006/main">
             <a:pPr algn="l">
+              <a:buNone/>
               <a:defRPr sz="900" b="0">
                 <a:solidFill>
                   <a:srgbClr val="5F6B64"/>
@@ -12990,6 +13155,7 @@
           <a:lstStyle xmlns:a="http://schemas.openxmlformats.org/drawingml/2006/main"/>
           <a:p xmlns:a="http://schemas.openxmlformats.org/drawingml/2006/main">
             <a:pPr algn="l">
+              <a:buNone/>
               <a:defRPr sz="2100" b="1">
                 <a:solidFill>
                   <a:srgbClr val="17202A"/>
@@ -13054,6 +13220,7 @@
           <a:lstStyle xmlns:a="http://schemas.openxmlformats.org/drawingml/2006/main"/>
           <a:p xmlns:a="http://schemas.openxmlformats.org/drawingml/2006/main">
             <a:pPr algn="l">
+              <a:buNone/>
               <a:defRPr sz="900" b="0">
                 <a:solidFill>
                   <a:srgbClr val="5F6B64"/>
@@ -13118,6 +13285,7 @@
           <a:lstStyle xmlns:a="http://schemas.openxmlformats.org/drawingml/2006/main"/>
           <a:p xmlns:a="http://schemas.openxmlformats.org/drawingml/2006/main">
             <a:pPr algn="l">
+              <a:buNone/>
               <a:defRPr sz="1050" b="0">
                 <a:solidFill>
                   <a:srgbClr val="17202A"/>
@@ -13182,6 +13350,7 @@
           <a:lstStyle xmlns:a="http://schemas.openxmlformats.org/drawingml/2006/main"/>
           <a:p xmlns:a="http://schemas.openxmlformats.org/drawingml/2006/main">
             <a:pPr algn="r">
+              <a:buNone/>
               <a:defRPr sz="750" b="0">
                 <a:solidFill>
                   <a:srgbClr val="5F6B64"/>
@@ -13338,6 +13507,7 @@
           <a:lstStyle xmlns:a="http://schemas.openxmlformats.org/drawingml/2006/main"/>
           <a:p xmlns:a="http://schemas.openxmlformats.org/drawingml/2006/main">
             <a:pPr algn="l">
+              <a:buNone/>
               <a:defRPr sz="900" b="1">
                 <a:solidFill>
                   <a:srgbClr val="0F8A6A"/>
@@ -13402,6 +13572,7 @@
           <a:lstStyle xmlns:a="http://schemas.openxmlformats.org/drawingml/2006/main"/>
           <a:p xmlns:a="http://schemas.openxmlformats.org/drawingml/2006/main">
             <a:pPr algn="l">
+              <a:buNone/>
               <a:defRPr sz="2325" b="1">
                 <a:solidFill>
                   <a:srgbClr val="17202A"/>
@@ -13499,6 +13670,7 @@
           <a:lstStyle xmlns:a="http://schemas.openxmlformats.org/drawingml/2006/main"/>
           <a:p xmlns:a="http://schemas.openxmlformats.org/drawingml/2006/main">
             <a:pPr algn="l">
+              <a:buNone/>
               <a:defRPr sz="1200" b="1">
                 <a:solidFill>
                   <a:srgbClr val="0F8A6A"/>
@@ -13563,6 +13735,7 @@
           <a:lstStyle xmlns:a="http://schemas.openxmlformats.org/drawingml/2006/main"/>
           <a:p xmlns:a="http://schemas.openxmlformats.org/drawingml/2006/main">
             <a:pPr algn="l">
+              <a:buNone/>
               <a:defRPr sz="863" b="0">
                 <a:solidFill>
                   <a:srgbClr val="17202A"/>
@@ -13660,6 +13833,7 @@
           <a:lstStyle xmlns:a="http://schemas.openxmlformats.org/drawingml/2006/main"/>
           <a:p xmlns:a="http://schemas.openxmlformats.org/drawingml/2006/main">
             <a:pPr algn="l">
+              <a:buNone/>
               <a:defRPr sz="1200" b="1">
                 <a:solidFill>
                   <a:srgbClr val="2E5EA7"/>
@@ -13724,6 +13898,7 @@
           <a:lstStyle xmlns:a="http://schemas.openxmlformats.org/drawingml/2006/main"/>
           <a:p xmlns:a="http://schemas.openxmlformats.org/drawingml/2006/main">
             <a:pPr algn="l">
+              <a:buNone/>
               <a:defRPr sz="863" b="0">
                 <a:solidFill>
                   <a:srgbClr val="17202A"/>
@@ -13821,6 +13996,7 @@
           <a:lstStyle xmlns:a="http://schemas.openxmlformats.org/drawingml/2006/main"/>
           <a:p xmlns:a="http://schemas.openxmlformats.org/drawingml/2006/main">
             <a:pPr algn="l">
+              <a:buNone/>
               <a:defRPr sz="1200" b="1">
                 <a:solidFill>
                   <a:srgbClr val="C98A21"/>
@@ -13885,6 +14061,7 @@
           <a:lstStyle xmlns:a="http://schemas.openxmlformats.org/drawingml/2006/main"/>
           <a:p xmlns:a="http://schemas.openxmlformats.org/drawingml/2006/main">
             <a:pPr algn="l">
+              <a:buNone/>
               <a:defRPr sz="863" b="0">
                 <a:solidFill>
                   <a:srgbClr val="17202A"/>
@@ -13982,6 +14159,7 @@
           <a:lstStyle xmlns:a="http://schemas.openxmlformats.org/drawingml/2006/main"/>
           <a:p xmlns:a="http://schemas.openxmlformats.org/drawingml/2006/main">
             <a:pPr algn="l">
+              <a:buNone/>
               <a:defRPr sz="1200" b="1">
                 <a:solidFill>
                   <a:srgbClr val="6559B7"/>
@@ -14046,6 +14224,7 @@
           <a:lstStyle xmlns:a="http://schemas.openxmlformats.org/drawingml/2006/main"/>
           <a:p xmlns:a="http://schemas.openxmlformats.org/drawingml/2006/main">
             <a:pPr algn="l">
+              <a:buNone/>
               <a:defRPr sz="863" b="0">
                 <a:solidFill>
                   <a:srgbClr val="17202A"/>
@@ -14143,6 +14322,7 @@
           <a:lstStyle xmlns:a="http://schemas.openxmlformats.org/drawingml/2006/main"/>
           <a:p xmlns:a="http://schemas.openxmlformats.org/drawingml/2006/main">
             <a:pPr algn="l">
+              <a:buNone/>
               <a:defRPr sz="1200" b="1">
                 <a:solidFill>
                   <a:srgbClr val="C85847"/>
@@ -14207,6 +14387,7 @@
           <a:lstStyle xmlns:a="http://schemas.openxmlformats.org/drawingml/2006/main"/>
           <a:p xmlns:a="http://schemas.openxmlformats.org/drawingml/2006/main">
             <a:pPr algn="l">
+              <a:buNone/>
               <a:defRPr sz="863" b="0">
                 <a:solidFill>
                   <a:srgbClr val="17202A"/>
@@ -14568,6 +14749,7 @@
           <a:lstStyle xmlns:a="http://schemas.openxmlformats.org/drawingml/2006/main"/>
           <a:p xmlns:a="http://schemas.openxmlformats.org/drawingml/2006/main">
             <a:pPr algn="ctr">
+              <a:buNone/>
               <a:defRPr sz="1200" b="0">
                 <a:solidFill>
                   <a:srgbClr val="5F6B64"/>
@@ -14632,6 +14814,7 @@
           <a:lstStyle xmlns:a="http://schemas.openxmlformats.org/drawingml/2006/main"/>
           <a:p xmlns:a="http://schemas.openxmlformats.org/drawingml/2006/main">
             <a:pPr algn="ctr">
+              <a:buNone/>
               <a:defRPr sz="1650" b="1">
                 <a:solidFill>
                   <a:srgbClr val="17202A"/>
@@ -14696,6 +14879,7 @@
           <a:lstStyle xmlns:a="http://schemas.openxmlformats.org/drawingml/2006/main"/>
           <a:p xmlns:a="http://schemas.openxmlformats.org/drawingml/2006/main">
             <a:pPr algn="r">
+              <a:buNone/>
               <a:defRPr sz="750" b="0">
                 <a:solidFill>
                   <a:srgbClr val="5F6B64"/>
@@ -14852,6 +15036,7 @@
           <a:lstStyle xmlns:a="http://schemas.openxmlformats.org/drawingml/2006/main"/>
           <a:p xmlns:a="http://schemas.openxmlformats.org/drawingml/2006/main">
             <a:pPr algn="l">
+              <a:buNone/>
               <a:defRPr sz="900" b="1">
                 <a:solidFill>
                   <a:srgbClr val="0F8A6A"/>
@@ -14916,6 +15101,7 @@
           <a:lstStyle xmlns:a="http://schemas.openxmlformats.org/drawingml/2006/main"/>
           <a:p xmlns:a="http://schemas.openxmlformats.org/drawingml/2006/main">
             <a:pPr algn="l">
+              <a:buNone/>
               <a:defRPr sz="2325" b="1">
                 <a:solidFill>
                   <a:srgbClr val="17202A"/>
@@ -15048,6 +15234,7 @@
           <a:lstStyle xmlns:a="http://schemas.openxmlformats.org/drawingml/2006/main"/>
           <a:p xmlns:a="http://schemas.openxmlformats.org/drawingml/2006/main">
             <a:pPr algn="l">
+              <a:buNone/>
               <a:defRPr sz="1275" b="1">
                 <a:solidFill>
                   <a:srgbClr val="17202A"/>
@@ -15112,6 +15299,7 @@
           <a:lstStyle xmlns:a="http://schemas.openxmlformats.org/drawingml/2006/main"/>
           <a:p xmlns:a="http://schemas.openxmlformats.org/drawingml/2006/main">
             <a:pPr algn="l">
+              <a:buNone/>
               <a:defRPr sz="938" b="0">
                 <a:solidFill>
                   <a:srgbClr val="5F6B64"/>
@@ -15244,6 +15432,7 @@
           <a:lstStyle xmlns:a="http://schemas.openxmlformats.org/drawingml/2006/main"/>
           <a:p xmlns:a="http://schemas.openxmlformats.org/drawingml/2006/main">
             <a:pPr algn="l">
+              <a:buNone/>
               <a:defRPr sz="1275" b="1">
                 <a:solidFill>
                   <a:srgbClr val="17202A"/>
@@ -15308,6 +15497,7 @@
           <a:lstStyle xmlns:a="http://schemas.openxmlformats.org/drawingml/2006/main"/>
           <a:p xmlns:a="http://schemas.openxmlformats.org/drawingml/2006/main">
             <a:pPr algn="l">
+              <a:buNone/>
               <a:defRPr sz="938" b="0">
                 <a:solidFill>
                   <a:srgbClr val="5F6B64"/>
@@ -15440,6 +15630,7 @@
           <a:lstStyle xmlns:a="http://schemas.openxmlformats.org/drawingml/2006/main"/>
           <a:p xmlns:a="http://schemas.openxmlformats.org/drawingml/2006/main">
             <a:pPr algn="l">
+              <a:buNone/>
               <a:defRPr sz="1275" b="1">
                 <a:solidFill>
                   <a:srgbClr val="17202A"/>
@@ -15504,6 +15695,7 @@
           <a:lstStyle xmlns:a="http://schemas.openxmlformats.org/drawingml/2006/main"/>
           <a:p xmlns:a="http://schemas.openxmlformats.org/drawingml/2006/main">
             <a:pPr algn="l">
+              <a:buNone/>
               <a:defRPr sz="938" b="0">
                 <a:solidFill>
                   <a:srgbClr val="5F6B64"/>
@@ -15636,6 +15828,7 @@
           <a:lstStyle xmlns:a="http://schemas.openxmlformats.org/drawingml/2006/main"/>
           <a:p xmlns:a="http://schemas.openxmlformats.org/drawingml/2006/main">
             <a:pPr algn="l">
+              <a:buNone/>
               <a:defRPr sz="1275" b="1">
                 <a:solidFill>
                   <a:srgbClr val="17202A"/>
@@ -15700,6 +15893,7 @@
           <a:lstStyle xmlns:a="http://schemas.openxmlformats.org/drawingml/2006/main"/>
           <a:p xmlns:a="http://schemas.openxmlformats.org/drawingml/2006/main">
             <a:pPr algn="l">
+              <a:buNone/>
               <a:defRPr sz="938" b="0">
                 <a:solidFill>
                   <a:srgbClr val="5F6B64"/>
@@ -15832,6 +16026,7 @@
           <a:lstStyle xmlns:a="http://schemas.openxmlformats.org/drawingml/2006/main"/>
           <a:p xmlns:a="http://schemas.openxmlformats.org/drawingml/2006/main">
             <a:pPr algn="l">
+              <a:buNone/>
               <a:defRPr sz="1275" b="1">
                 <a:solidFill>
                   <a:srgbClr val="17202A"/>
@@ -15896,6 +16091,7 @@
           <a:lstStyle xmlns:a="http://schemas.openxmlformats.org/drawingml/2006/main"/>
           <a:p xmlns:a="http://schemas.openxmlformats.org/drawingml/2006/main">
             <a:pPr algn="l">
+              <a:buNone/>
               <a:defRPr sz="938" b="0">
                 <a:solidFill>
                   <a:srgbClr val="5F6B64"/>
@@ -16224,6 +16420,7 @@
           <a:lstStyle xmlns:a="http://schemas.openxmlformats.org/drawingml/2006/main"/>
           <a:p xmlns:a="http://schemas.openxmlformats.org/drawingml/2006/main">
             <a:pPr algn="ctr">
+              <a:buNone/>
               <a:defRPr sz="1350" b="1">
                 <a:solidFill>
                   <a:srgbClr val="17202A"/>
@@ -16288,6 +16485,7 @@
           <a:lstStyle xmlns:a="http://schemas.openxmlformats.org/drawingml/2006/main"/>
           <a:p xmlns:a="http://schemas.openxmlformats.org/drawingml/2006/main">
             <a:pPr algn="ctr">
+              <a:buNone/>
               <a:defRPr sz="1088" b="0">
                 <a:solidFill>
                   <a:srgbClr val="5F6B64"/>
@@ -16352,6 +16550,7 @@
           <a:lstStyle xmlns:a="http://schemas.openxmlformats.org/drawingml/2006/main"/>
           <a:p xmlns:a="http://schemas.openxmlformats.org/drawingml/2006/main">
             <a:pPr algn="r">
+              <a:buNone/>
               <a:defRPr sz="750" b="0">
                 <a:solidFill>
                   <a:srgbClr val="5F6B64"/>
@@ -16508,6 +16707,7 @@
           <a:lstStyle xmlns:a="http://schemas.openxmlformats.org/drawingml/2006/main"/>
           <a:p xmlns:a="http://schemas.openxmlformats.org/drawingml/2006/main">
             <a:pPr algn="l">
+              <a:buNone/>
               <a:defRPr sz="900" b="1">
                 <a:solidFill>
                   <a:srgbClr val="0F8A6A"/>
@@ -16572,6 +16772,7 @@
           <a:lstStyle xmlns:a="http://schemas.openxmlformats.org/drawingml/2006/main"/>
           <a:p xmlns:a="http://schemas.openxmlformats.org/drawingml/2006/main">
             <a:pPr algn="l">
+              <a:buNone/>
               <a:defRPr sz="2325" b="1">
                 <a:solidFill>
                   <a:srgbClr val="17202A"/>
@@ -16669,6 +16870,7 @@
           <a:lstStyle xmlns:a="http://schemas.openxmlformats.org/drawingml/2006/main"/>
           <a:p xmlns:a="http://schemas.openxmlformats.org/drawingml/2006/main">
             <a:pPr algn="ctr">
+              <a:buNone/>
               <a:defRPr sz="788" b="1">
                 <a:solidFill>
                   <a:srgbClr val="C85847"/>
@@ -16801,6 +17003,7 @@
           <a:lstStyle xmlns:a="http://schemas.openxmlformats.org/drawingml/2006/main"/>
           <a:p xmlns:a="http://schemas.openxmlformats.org/drawingml/2006/main">
             <a:pPr algn="l">
+              <a:buNone/>
               <a:defRPr sz="1275" b="1">
                 <a:solidFill>
                   <a:srgbClr val="17202A"/>
@@ -16865,6 +17068,7 @@
           <a:lstStyle xmlns:a="http://schemas.openxmlformats.org/drawingml/2006/main"/>
           <a:p xmlns:a="http://schemas.openxmlformats.org/drawingml/2006/main">
             <a:pPr algn="l">
+              <a:buNone/>
               <a:defRPr sz="938" b="0">
                 <a:solidFill>
                   <a:srgbClr val="5F6B64"/>
@@ -16997,6 +17201,7 @@
           <a:lstStyle xmlns:a="http://schemas.openxmlformats.org/drawingml/2006/main"/>
           <a:p xmlns:a="http://schemas.openxmlformats.org/drawingml/2006/main">
             <a:pPr algn="l">
+              <a:buNone/>
               <a:defRPr sz="1275" b="1">
                 <a:solidFill>
                   <a:srgbClr val="17202A"/>
@@ -17061,6 +17266,7 @@
           <a:lstStyle xmlns:a="http://schemas.openxmlformats.org/drawingml/2006/main"/>
           <a:p xmlns:a="http://schemas.openxmlformats.org/drawingml/2006/main">
             <a:pPr algn="l">
+              <a:buNone/>
               <a:defRPr sz="938" b="0">
                 <a:solidFill>
                   <a:srgbClr val="5F6B64"/>
@@ -17193,6 +17399,7 @@
           <a:lstStyle xmlns:a="http://schemas.openxmlformats.org/drawingml/2006/main"/>
           <a:p xmlns:a="http://schemas.openxmlformats.org/drawingml/2006/main">
             <a:pPr algn="l">
+              <a:buNone/>
               <a:defRPr sz="1275" b="1">
                 <a:solidFill>
                   <a:srgbClr val="17202A"/>
@@ -17257,6 +17464,7 @@
           <a:lstStyle xmlns:a="http://schemas.openxmlformats.org/drawingml/2006/main"/>
           <a:p xmlns:a="http://schemas.openxmlformats.org/drawingml/2006/main">
             <a:pPr algn="l">
+              <a:buNone/>
               <a:defRPr sz="938" b="0">
                 <a:solidFill>
                   <a:srgbClr val="5F6B64"/>
@@ -17389,6 +17597,7 @@
           <a:lstStyle xmlns:a="http://schemas.openxmlformats.org/drawingml/2006/main"/>
           <a:p xmlns:a="http://schemas.openxmlformats.org/drawingml/2006/main">
             <a:pPr algn="l">
+              <a:buNone/>
               <a:defRPr sz="1275" b="1">
                 <a:solidFill>
                   <a:srgbClr val="17202A"/>
@@ -17453,6 +17662,7 @@
           <a:lstStyle xmlns:a="http://schemas.openxmlformats.org/drawingml/2006/main"/>
           <a:p xmlns:a="http://schemas.openxmlformats.org/drawingml/2006/main">
             <a:pPr algn="l">
+              <a:buNone/>
               <a:defRPr sz="938" b="0">
                 <a:solidFill>
                   <a:srgbClr val="5F6B64"/>
@@ -17550,6 +17760,7 @@
           <a:lstStyle xmlns:a="http://schemas.openxmlformats.org/drawingml/2006/main"/>
           <a:p xmlns:a="http://schemas.openxmlformats.org/drawingml/2006/main">
             <a:pPr algn="ctr">
+              <a:buNone/>
               <a:defRPr sz="1350" b="0">
                 <a:solidFill>
                   <a:srgbClr val="5F6B64"/>
@@ -17614,6 +17825,7 @@
           <a:lstStyle xmlns:a="http://schemas.openxmlformats.org/drawingml/2006/main"/>
           <a:p xmlns:a="http://schemas.openxmlformats.org/drawingml/2006/main">
             <a:pPr algn="ctr">
+              <a:buNone/>
               <a:defRPr sz="1725" b="1">
                 <a:solidFill>
                   <a:srgbClr val="17202A"/>
@@ -17678,6 +17890,7 @@
           <a:lstStyle xmlns:a="http://schemas.openxmlformats.org/drawingml/2006/main"/>
           <a:p xmlns:a="http://schemas.openxmlformats.org/drawingml/2006/main">
             <a:pPr algn="r">
+              <a:buNone/>
               <a:defRPr sz="750" b="0">
                 <a:solidFill>
                   <a:srgbClr val="5F6B64"/>
@@ -17834,6 +18047,7 @@
           <a:lstStyle xmlns:a="http://schemas.openxmlformats.org/drawingml/2006/main"/>
           <a:p xmlns:a="http://schemas.openxmlformats.org/drawingml/2006/main">
             <a:pPr algn="l">
+              <a:buNone/>
               <a:defRPr sz="900" b="1">
                 <a:solidFill>
                   <a:srgbClr val="0F8A6A"/>
@@ -17898,6 +18112,7 @@
           <a:lstStyle xmlns:a="http://schemas.openxmlformats.org/drawingml/2006/main"/>
           <a:p xmlns:a="http://schemas.openxmlformats.org/drawingml/2006/main">
             <a:pPr algn="l">
+              <a:buNone/>
               <a:defRPr sz="2325" b="1">
                 <a:solidFill>
                   <a:srgbClr val="17202A"/>
@@ -18030,6 +18245,7 @@
           <a:lstStyle xmlns:a="http://schemas.openxmlformats.org/drawingml/2006/main"/>
           <a:p xmlns:a="http://schemas.openxmlformats.org/drawingml/2006/main">
             <a:pPr algn="l">
+              <a:buNone/>
               <a:defRPr sz="1275" b="1">
                 <a:solidFill>
                   <a:srgbClr val="17202A"/>
@@ -18094,6 +18310,7 @@
           <a:lstStyle xmlns:a="http://schemas.openxmlformats.org/drawingml/2006/main"/>
           <a:p xmlns:a="http://schemas.openxmlformats.org/drawingml/2006/main">
             <a:pPr algn="l">
+              <a:buNone/>
               <a:defRPr sz="938" b="0">
                 <a:solidFill>
                   <a:srgbClr val="5F6B64"/>
@@ -18117,6 +18334,7 @@
           </a:p>
           <a:p xmlns:a="http://schemas.openxmlformats.org/drawingml/2006/main">
             <a:pPr algn="l">
+              <a:buNone/>
               <a:defRPr sz="938" b="0">
                 <a:solidFill>
                   <a:srgbClr val="5F6B64"/>
@@ -18140,6 +18358,7 @@
           </a:p>
           <a:p xmlns:a="http://schemas.openxmlformats.org/drawingml/2006/main">
             <a:pPr algn="l">
+              <a:buNone/>
               <a:defRPr sz="938" b="0">
                 <a:solidFill>
                   <a:srgbClr val="5F6B64"/>
@@ -18163,6 +18382,7 @@
           </a:p>
           <a:p xmlns:a="http://schemas.openxmlformats.org/drawingml/2006/main">
             <a:pPr algn="l">
+              <a:buNone/>
               <a:defRPr sz="938" b="0">
                 <a:solidFill>
                   <a:srgbClr val="5F6B64"/>
@@ -18186,6 +18406,7 @@
           </a:p>
           <a:p xmlns:a="http://schemas.openxmlformats.org/drawingml/2006/main">
             <a:pPr algn="l">
+              <a:buNone/>
               <a:defRPr sz="938" b="0">
                 <a:solidFill>
                   <a:srgbClr val="5F6B64"/>
@@ -18318,6 +18539,7 @@
           <a:lstStyle xmlns:a="http://schemas.openxmlformats.org/drawingml/2006/main"/>
           <a:p xmlns:a="http://schemas.openxmlformats.org/drawingml/2006/main">
             <a:pPr algn="l">
+              <a:buNone/>
               <a:defRPr sz="1275" b="1">
                 <a:solidFill>
                   <a:srgbClr val="17202A"/>
@@ -18382,6 +18604,7 @@
           <a:lstStyle xmlns:a="http://schemas.openxmlformats.org/drawingml/2006/main"/>
           <a:p xmlns:a="http://schemas.openxmlformats.org/drawingml/2006/main">
             <a:pPr algn="l">
+              <a:buNone/>
               <a:defRPr sz="938" b="0">
                 <a:solidFill>
                   <a:srgbClr val="5F6B64"/>
@@ -18405,6 +18628,7 @@
           </a:p>
           <a:p xmlns:a="http://schemas.openxmlformats.org/drawingml/2006/main">
             <a:pPr algn="l">
+              <a:buNone/>
               <a:defRPr sz="938" b="0">
                 <a:solidFill>
                   <a:srgbClr val="5F6B64"/>
@@ -18428,6 +18652,7 @@
           </a:p>
           <a:p xmlns:a="http://schemas.openxmlformats.org/drawingml/2006/main">
             <a:pPr algn="l">
+              <a:buNone/>
               <a:defRPr sz="938" b="0">
                 <a:solidFill>
                   <a:srgbClr val="5F6B64"/>
@@ -18451,6 +18676,7 @@
           </a:p>
           <a:p xmlns:a="http://schemas.openxmlformats.org/drawingml/2006/main">
             <a:pPr algn="l">
+              <a:buNone/>
               <a:defRPr sz="938" b="0">
                 <a:solidFill>
                   <a:srgbClr val="5F6B64"/>
@@ -18474,6 +18700,7 @@
           </a:p>
           <a:p xmlns:a="http://schemas.openxmlformats.org/drawingml/2006/main">
             <a:pPr algn="l">
+              <a:buNone/>
               <a:defRPr sz="938" b="0">
                 <a:solidFill>
                   <a:srgbClr val="5F6B64"/>
@@ -18571,6 +18798,7 @@
           <a:lstStyle xmlns:a="http://schemas.openxmlformats.org/drawingml/2006/main"/>
           <a:p xmlns:a="http://schemas.openxmlformats.org/drawingml/2006/main">
             <a:pPr algn="ctr">
+              <a:buNone/>
               <a:defRPr sz="1350" b="1">
                 <a:solidFill>
                   <a:srgbClr val="17202A"/>
@@ -18635,6 +18863,7 @@
           <a:lstStyle xmlns:a="http://schemas.openxmlformats.org/drawingml/2006/main"/>
           <a:p xmlns:a="http://schemas.openxmlformats.org/drawingml/2006/main">
             <a:pPr algn="r">
+              <a:buNone/>
               <a:defRPr sz="750" b="0">
                 <a:solidFill>
                   <a:srgbClr val="5F6B64"/>

</xml_diff>

<commit_message>
Adjust closing slide logo placement
</commit_message>
<xml_diff>
--- a/deliverables/Robo-T-Rader_OpenAI_Build_Week_2026.pptx
+++ b/deliverables/Robo-T-Rader_OpenAI_Build_Week_2026.pptx
@@ -2,22 +2,22 @@
 <file path=ppt/presentation.xml><?xml version="1.0" encoding="utf-8"?>
 <p:presentation xmlns:p="http://schemas.openxmlformats.org/presentationml/2006/main">
   <p:sldMasterIdLst>
-    <p:sldMasterId xmlns:r="http://schemas.openxmlformats.org/officeDocument/2006/relationships" id="2147483648" r:id="Rc58b740cd73649bc"/>
+    <p:sldMasterId xmlns:r="http://schemas.openxmlformats.org/officeDocument/2006/relationships" id="2147483648" r:id="Rfb599ace06504e35"/>
   </p:sldMasterIdLst>
   <p:notesMasterIdLst>
-    <p:notesMasterId xmlns:r="http://schemas.openxmlformats.org/officeDocument/2006/relationships" r:id="R1202769f2312400b"/>
+    <p:notesMasterId xmlns:r="http://schemas.openxmlformats.org/officeDocument/2006/relationships" r:id="R83958e6f92364cbc"/>
   </p:notesMasterIdLst>
   <p:sldIdLst>
-    <p:sldId xmlns:r="http://schemas.openxmlformats.org/officeDocument/2006/relationships" id="256" r:id="Rf695aa83d1734a8d"/>
-    <p:sldId xmlns:r="http://schemas.openxmlformats.org/officeDocument/2006/relationships" id="257" r:id="Refa66d3726c54257"/>
-    <p:sldId xmlns:r="http://schemas.openxmlformats.org/officeDocument/2006/relationships" id="258" r:id="Rc1a701c4d6544738"/>
-    <p:sldId xmlns:r="http://schemas.openxmlformats.org/officeDocument/2006/relationships" id="259" r:id="R1c3e187fa01d4381"/>
-    <p:sldId xmlns:r="http://schemas.openxmlformats.org/officeDocument/2006/relationships" id="260" r:id="Re7d113e59e284240"/>
-    <p:sldId xmlns:r="http://schemas.openxmlformats.org/officeDocument/2006/relationships" id="261" r:id="Rca64f05c918549b6"/>
-    <p:sldId xmlns:r="http://schemas.openxmlformats.org/officeDocument/2006/relationships" id="262" r:id="R535747d4987a4ae9"/>
-    <p:sldId xmlns:r="http://schemas.openxmlformats.org/officeDocument/2006/relationships" id="263" r:id="R7e0e182465c6465d"/>
-    <p:sldId xmlns:r="http://schemas.openxmlformats.org/officeDocument/2006/relationships" id="264" r:id="R5cb6238a4d9f465c"/>
-    <p:sldId xmlns:r="http://schemas.openxmlformats.org/officeDocument/2006/relationships" id="265" r:id="Rbfa45cb58cba41d4"/>
+    <p:sldId xmlns:r="http://schemas.openxmlformats.org/officeDocument/2006/relationships" id="256" r:id="Re85942ac1fea4c81"/>
+    <p:sldId xmlns:r="http://schemas.openxmlformats.org/officeDocument/2006/relationships" id="257" r:id="R7ad698423490418c"/>
+    <p:sldId xmlns:r="http://schemas.openxmlformats.org/officeDocument/2006/relationships" id="258" r:id="R1a12b091d74e4959"/>
+    <p:sldId xmlns:r="http://schemas.openxmlformats.org/officeDocument/2006/relationships" id="259" r:id="R9a09d846c31e4e32"/>
+    <p:sldId xmlns:r="http://schemas.openxmlformats.org/officeDocument/2006/relationships" id="260" r:id="R72b929a8d7af4533"/>
+    <p:sldId xmlns:r="http://schemas.openxmlformats.org/officeDocument/2006/relationships" id="261" r:id="R3c11ed85880a4a22"/>
+    <p:sldId xmlns:r="http://schemas.openxmlformats.org/officeDocument/2006/relationships" id="262" r:id="Rfa8f8dd58cdf4f6e"/>
+    <p:sldId xmlns:r="http://schemas.openxmlformats.org/officeDocument/2006/relationships" id="263" r:id="Rfcc4663ff53b4111"/>
+    <p:sldId xmlns:r="http://schemas.openxmlformats.org/officeDocument/2006/relationships" id="264" r:id="R157e87ee3ff34a67"/>
+    <p:sldId xmlns:r="http://schemas.openxmlformats.org/officeDocument/2006/relationships" id="265" r:id="R7886375bb4c44362"/>
   </p:sldIdLst>
   <p:sldSz cx="12192000" cy="6858000"/>
   <p:notesSz cx="6858000" cy="9144000"/>
@@ -1158,7 +1158,7 @@
   </p:cSld>
   <p:clrMap bg1="lt1" tx1="dk1" bg2="lt2" tx2="dk2" accent1="accent1" accent2="accent2" accent3="accent3" accent4="accent4" accent5="accent5" accent6="accent6" hlink="hlink" folHlink="folHlink"/>
   <p:sldLayoutIdLst>
-    <p:sldLayoutId xmlns:r="http://schemas.openxmlformats.org/officeDocument/2006/relationships" id="2147483649" r:id="Rdbc38080a8e546d1"/>
+    <p:sldLayoutId xmlns:r="http://schemas.openxmlformats.org/officeDocument/2006/relationships" id="2147483649" r:id="R5c1c2e1202ed4723"/>
   </p:sldLayoutIdLst>
   <p:txStyles>
     <p:titleStyle>
@@ -3528,7 +3528,7 @@
           <p:nvPr/>
         </p:nvPicPr>
         <p:blipFill>
-          <a:blip xmlns:r="http://schemas.openxmlformats.org/officeDocument/2006/relationships" xmlns:a="http://schemas.openxmlformats.org/drawingml/2006/main" r:embed="R53d4f7b6782b4c68"/>
+          <a:blip xmlns:r="http://schemas.openxmlformats.org/officeDocument/2006/relationships" xmlns:a="http://schemas.openxmlformats.org/drawingml/2006/main" r:embed="R53d6e359e9b14312"/>
           <a:stretch xmlns:a="http://schemas.openxmlformats.org/drawingml/2006/main"/>
         </p:blipFill>
         <p:spPr>
@@ -5111,13 +5111,68 @@
           <p:nvPr/>
         </p:nvPicPr>
         <p:blipFill>
-          <a:blip xmlns:r="http://schemas.openxmlformats.org/officeDocument/2006/relationships" xmlns:a="http://schemas.openxmlformats.org/drawingml/2006/main" r:embed="Rb154235000424b0a"/>
+          <a:blip xmlns:r="http://schemas.openxmlformats.org/officeDocument/2006/relationships" xmlns:a="http://schemas.openxmlformats.org/drawingml/2006/main" r:embed="Raef0bbeeb8e6424d"/>
           <a:stretch xmlns:a="http://schemas.openxmlformats.org/drawingml/2006/main"/>
         </p:blipFill>
         <p:spPr>
           <a:xfrm xmlns:a="http://schemas.openxmlformats.org/drawingml/2006/main">
             <a:off x="8766913" y="4476750"/>
             <a:ext cx="1801924" cy="1123950"/>
+          </a:xfrm>
+          <a:prstGeom xmlns:a="http://schemas.openxmlformats.org/drawingml/2006/main" prst="rect">
+            <a:avLst/>
+          </a:prstGeom>
+        </p:spPr>
+      </p:pic>
+      <p:sp>
+        <p:nvSpPr>
+          <p:cNvPr id="33" name="logo-cleanup-mask">
+            <a:extLst xmlns:a="http://schemas.openxmlformats.org/drawingml/2006/main">
+              <a:ext uri="{FF2B5EF4-FFF2-40B4-BE49-F238E27FC236}">
+                <a16:creationId xmlns:a16="http://schemas.microsoft.com/office/drawing/2014/main" id="{3D1748BE-201F-420E-857A-32773D81969B}"/>
+              </a:ext>
+            </a:extLst>
+          </p:cNvPr>
+          <p:cNvSpPr>
+            <a:spLocks xmlns:a="http://schemas.openxmlformats.org/drawingml/2006/main" noGrp="1"/>
+          </p:cNvSpPr>
+          <p:nvPr/>
+        </p:nvSpPr>
+        <p:spPr>
+          <a:xfrm xmlns:a="http://schemas.openxmlformats.org/drawingml/2006/main">
+            <a:off x="8858250" y="4333875"/>
+            <a:ext cx="2476500" cy="1524000"/>
+          </a:xfrm>
+          <a:prstGeom xmlns:a="http://schemas.openxmlformats.org/drawingml/2006/main" prst="rect">
+            <a:avLst/>
+          </a:prstGeom>
+          <a:solidFill xmlns:a="http://schemas.openxmlformats.org/drawingml/2006/main">
+            <a:srgbClr val="11181F"/>
+          </a:solidFill>
+          <a:ln xmlns:a="http://schemas.openxmlformats.org/drawingml/2006/main" w="0">
+            <a:solidFill>
+              <a:srgbClr val="11181F"/>
+            </a:solidFill>
+            <a:prstDash val="solid"/>
+          </a:ln>
+        </p:spPr>
+      </p:sp>
+      <p:pic>
+        <p:nvPicPr>
+          <p:cNvPr id="34" name=""/>
+          <p:cNvPicPr>
+            <a:picLocks xmlns:a="http://schemas.openxmlformats.org/drawingml/2006/main" noChangeAspect="1"/>
+          </p:cNvPicPr>
+          <p:nvPr/>
+        </p:nvPicPr>
+        <p:blipFill>
+          <a:blip xmlns:r="http://schemas.openxmlformats.org/officeDocument/2006/relationships" xmlns:a="http://schemas.openxmlformats.org/drawingml/2006/main" r:embed="Rae3414bc2b274eea"/>
+          <a:stretch xmlns:a="http://schemas.openxmlformats.org/drawingml/2006/main"/>
+        </p:blipFill>
+        <p:spPr>
+          <a:xfrm xmlns:a="http://schemas.openxmlformats.org/drawingml/2006/main">
+            <a:off x="9409326" y="5000625"/>
+            <a:ext cx="1374349" cy="857250"/>
           </a:xfrm>
           <a:prstGeom xmlns:a="http://schemas.openxmlformats.org/drawingml/2006/main" prst="rect">
             <a:avLst/>

</xml_diff>